<commit_message>
Update Professional Networking and Open Knowledge Sharing Services' Lean Business Cases
</commit_message>
<xml_diff>
--- a/docs/2_Value_Creation/2a_Product/Open Knowledge Sharing/Open Knowledge Sharing v1 Lean Business Case.pptx
+++ b/docs/2_Value_Creation/2a_Product/Open Knowledge Sharing/Open Knowledge Sharing v1 Lean Business Case.pptx
@@ -270,7 +270,7 @@
 <file path=ppt/revisionInfo.xml><?xml version="1.0" encoding="utf-8"?>
 <p1510:revInfo xmlns:a="http://schemas.openxmlformats.org/drawingml/2006/main" xmlns:r="http://schemas.openxmlformats.org/officeDocument/2006/relationships" xmlns:p1510="http://schemas.microsoft.com/office/powerpoint/2015/10/main">
   <p1510:revLst>
-    <p1510:client id="{56979323-92D1-2645-918B-5AF322CBD296}" v="37" dt="2024-11-01T20:14:32.798"/>
+    <p1510:client id="{5AC05174-BA9D-FB4D-903E-06F7B3087031}" v="2" dt="2026-08-09T19:40:57.788"/>
   </p1510:revLst>
 </p1510:revInfo>
 </file>
@@ -278,28 +278,20 @@
 <file path=ppt/changesInfos/changesInfo1.xml><?xml version="1.0" encoding="utf-8"?>
 <pc:chgInfo xmlns:a="http://schemas.openxmlformats.org/drawingml/2006/main" xmlns:r="http://schemas.openxmlformats.org/officeDocument/2006/relationships" xmlns:ac="http://schemas.microsoft.com/office/drawing/2013/main/command" xmlns:pc="http://schemas.microsoft.com/office/powerpoint/2013/main/command">
   <pc:docChgLst>
-    <pc:chgData name="Rich Reba" userId="8245d172-5b81-40f1-a13b-b71f02cd6700" providerId="ADAL" clId="{56979323-92D1-2645-918B-5AF322CBD296}"/>
-    <pc:docChg chg="undo redo custSel addSld delSld modSld">
-      <pc:chgData name="Rich Reba" userId="8245d172-5b81-40f1-a13b-b71f02cd6700" providerId="ADAL" clId="{56979323-92D1-2645-918B-5AF322CBD296}" dt="2024-11-01T20:28:13.827" v="2307" actId="20577"/>
+    <pc:chgData name="Rich Reba" userId="55db41ab6eb3f845" providerId="LiveId" clId="{0E19DA16-244C-5B50-BE0F-52911DD4CA7E}"/>
+    <pc:docChg chg="custSel modSld">
+      <pc:chgData name="Rich Reba" userId="55db41ab6eb3f845" providerId="LiveId" clId="{0E19DA16-244C-5B50-BE0F-52911DD4CA7E}" dt="2026-08-09T19:40:57.788" v="838"/>
       <pc:docMkLst>
         <pc:docMk/>
       </pc:docMkLst>
       <pc:sldChg chg="modSp mod">
-        <pc:chgData name="Rich Reba" userId="8245d172-5b81-40f1-a13b-b71f02cd6700" providerId="ADAL" clId="{56979323-92D1-2645-918B-5AF322CBD296}" dt="2024-11-01T19:03:01.777" v="1934" actId="14100"/>
+        <pc:chgData name="Rich Reba" userId="55db41ab6eb3f845" providerId="LiveId" clId="{0E19DA16-244C-5B50-BE0F-52911DD4CA7E}" dt="2026-08-09T19:29:08.650" v="46" actId="20577"/>
         <pc:sldMkLst>
           <pc:docMk/>
           <pc:sldMk cId="0" sldId="256"/>
         </pc:sldMkLst>
         <pc:spChg chg="mod">
-          <ac:chgData name="Rich Reba" userId="8245d172-5b81-40f1-a13b-b71f02cd6700" providerId="ADAL" clId="{56979323-92D1-2645-918B-5AF322CBD296}" dt="2024-11-01T19:03:01.777" v="1934" actId="14100"/>
-          <ac:spMkLst>
-            <pc:docMk/>
-            <pc:sldMk cId="0" sldId="256"/>
-            <ac:spMk id="90" creationId="{00000000-0000-0000-0000-000000000000}"/>
-          </ac:spMkLst>
-        </pc:spChg>
-        <pc:spChg chg="mod">
-          <ac:chgData name="Rich Reba" userId="8245d172-5b81-40f1-a13b-b71f02cd6700" providerId="ADAL" clId="{56979323-92D1-2645-918B-5AF322CBD296}" dt="2024-11-01T17:51:01.500" v="756" actId="20577"/>
+          <ac:chgData name="Rich Reba" userId="55db41ab6eb3f845" providerId="LiveId" clId="{0E19DA16-244C-5B50-BE0F-52911DD4CA7E}" dt="2026-08-09T19:29:08.650" v="46" actId="20577"/>
           <ac:spMkLst>
             <pc:docMk/>
             <pc:sldMk cId="0" sldId="256"/>
@@ -308,29 +300,13 @@
         </pc:spChg>
       </pc:sldChg>
       <pc:sldChg chg="modSp mod">
-        <pc:chgData name="Rich Reba" userId="8245d172-5b81-40f1-a13b-b71f02cd6700" providerId="ADAL" clId="{56979323-92D1-2645-918B-5AF322CBD296}" dt="2024-11-01T20:14:37.808" v="2300" actId="20577"/>
+        <pc:chgData name="Rich Reba" userId="55db41ab6eb3f845" providerId="LiveId" clId="{0E19DA16-244C-5B50-BE0F-52911DD4CA7E}" dt="2026-08-09T19:40:41.181" v="837" actId="20577"/>
         <pc:sldMkLst>
           <pc:docMk/>
           <pc:sldMk cId="1272635936" sldId="264"/>
         </pc:sldMkLst>
-        <pc:spChg chg="mod">
-          <ac:chgData name="Rich Reba" userId="8245d172-5b81-40f1-a13b-b71f02cd6700" providerId="ADAL" clId="{56979323-92D1-2645-918B-5AF322CBD296}" dt="2024-10-25T17:53:04.210" v="302" actId="1035"/>
-          <ac:spMkLst>
-            <pc:docMk/>
-            <pc:sldMk cId="1272635936" sldId="264"/>
-            <ac:spMk id="6" creationId="{F57F7845-FD8A-DCA4-39DB-1B7D9CF0BA2A}"/>
-          </ac:spMkLst>
-        </pc:spChg>
-        <pc:spChg chg="mod">
-          <ac:chgData name="Rich Reba" userId="8245d172-5b81-40f1-a13b-b71f02cd6700" providerId="ADAL" clId="{56979323-92D1-2645-918B-5AF322CBD296}" dt="2024-11-01T20:14:37.808" v="2300" actId="20577"/>
-          <ac:spMkLst>
-            <pc:docMk/>
-            <pc:sldMk cId="1272635936" sldId="264"/>
-            <ac:spMk id="96" creationId="{00000000-0000-0000-0000-000000000000}"/>
-          </ac:spMkLst>
-        </pc:spChg>
-        <pc:graphicFrameChg chg="mod modGraphic">
-          <ac:chgData name="Rich Reba" userId="8245d172-5b81-40f1-a13b-b71f02cd6700" providerId="ADAL" clId="{56979323-92D1-2645-918B-5AF322CBD296}" dt="2024-10-25T17:55:06.991" v="418" actId="20577"/>
+        <pc:graphicFrameChg chg="modGraphic">
+          <ac:chgData name="Rich Reba" userId="55db41ab6eb3f845" providerId="LiveId" clId="{0E19DA16-244C-5B50-BE0F-52911DD4CA7E}" dt="2026-08-09T19:40:41.181" v="837" actId="20577"/>
           <ac:graphicFrameMkLst>
             <pc:docMk/>
             <pc:sldMk cId="1272635936" sldId="264"/>
@@ -338,21 +314,14 @@
           </ac:graphicFrameMkLst>
         </pc:graphicFrameChg>
       </pc:sldChg>
-      <pc:sldChg chg="del">
-        <pc:chgData name="Rich Reba" userId="8245d172-5b81-40f1-a13b-b71f02cd6700" providerId="ADAL" clId="{56979323-92D1-2645-918B-5AF322CBD296}" dt="2024-10-25T17:55:42.461" v="420" actId="2696"/>
-        <pc:sldMkLst>
-          <pc:docMk/>
-          <pc:sldMk cId="4188122143" sldId="266"/>
-        </pc:sldMkLst>
-      </pc:sldChg>
       <pc:sldChg chg="modSp mod">
-        <pc:chgData name="Rich Reba" userId="8245d172-5b81-40f1-a13b-b71f02cd6700" providerId="ADAL" clId="{56979323-92D1-2645-918B-5AF322CBD296}" dt="2024-11-01T20:14:34.627" v="2298" actId="20577"/>
+        <pc:chgData name="Rich Reba" userId="55db41ab6eb3f845" providerId="LiveId" clId="{0E19DA16-244C-5B50-BE0F-52911DD4CA7E}" dt="2026-08-09T19:32:35.410" v="358" actId="20577"/>
         <pc:sldMkLst>
           <pc:docMk/>
           <pc:sldMk cId="1243007551" sldId="268"/>
         </pc:sldMkLst>
-        <pc:graphicFrameChg chg="mod modGraphic">
-          <ac:chgData name="Rich Reba" userId="8245d172-5b81-40f1-a13b-b71f02cd6700" providerId="ADAL" clId="{56979323-92D1-2645-918B-5AF322CBD296}" dt="2024-11-01T20:14:34.627" v="2298" actId="20577"/>
+        <pc:graphicFrameChg chg="modGraphic">
+          <ac:chgData name="Rich Reba" userId="55db41ab6eb3f845" providerId="LiveId" clId="{0E19DA16-244C-5B50-BE0F-52911DD4CA7E}" dt="2026-08-09T19:32:35.410" v="358" actId="20577"/>
           <ac:graphicFrameMkLst>
             <pc:docMk/>
             <pc:sldMk cId="1243007551" sldId="268"/>
@@ -360,30 +329,14 @@
           </ac:graphicFrameMkLst>
         </pc:graphicFrameChg>
       </pc:sldChg>
-      <pc:sldChg chg="delSp modSp mod">
-        <pc:chgData name="Rich Reba" userId="8245d172-5b81-40f1-a13b-b71f02cd6700" providerId="ADAL" clId="{56979323-92D1-2645-918B-5AF322CBD296}" dt="2024-11-01T19:14:01.938" v="2161" actId="20577"/>
+      <pc:sldChg chg="modSp mod">
+        <pc:chgData name="Rich Reba" userId="55db41ab6eb3f845" providerId="LiveId" clId="{0E19DA16-244C-5B50-BE0F-52911DD4CA7E}" dt="2026-08-09T19:33:21.908" v="435" actId="20577"/>
         <pc:sldMkLst>
           <pc:docMk/>
           <pc:sldMk cId="450257364" sldId="269"/>
         </pc:sldMkLst>
-        <pc:spChg chg="del">
-          <ac:chgData name="Rich Reba" userId="8245d172-5b81-40f1-a13b-b71f02cd6700" providerId="ADAL" clId="{56979323-92D1-2645-918B-5AF322CBD296}" dt="2024-11-01T18:04:31.703" v="916" actId="478"/>
-          <ac:spMkLst>
-            <pc:docMk/>
-            <pc:sldMk cId="450257364" sldId="269"/>
-            <ac:spMk id="6" creationId="{7EAC0157-6343-D56D-5D76-3AAA75837A76}"/>
-          </ac:spMkLst>
-        </pc:spChg>
-        <pc:spChg chg="mod">
-          <ac:chgData name="Rich Reba" userId="8245d172-5b81-40f1-a13b-b71f02cd6700" providerId="ADAL" clId="{56979323-92D1-2645-918B-5AF322CBD296}" dt="2024-11-01T18:04:37.255" v="920" actId="1036"/>
-          <ac:spMkLst>
-            <pc:docMk/>
-            <pc:sldMk cId="450257364" sldId="269"/>
-            <ac:spMk id="7" creationId="{31CA48FC-F211-DAFD-902B-5D682C6B56DD}"/>
-          </ac:spMkLst>
-        </pc:spChg>
-        <pc:graphicFrameChg chg="mod modGraphic">
-          <ac:chgData name="Rich Reba" userId="8245d172-5b81-40f1-a13b-b71f02cd6700" providerId="ADAL" clId="{56979323-92D1-2645-918B-5AF322CBD296}" dt="2024-11-01T19:14:01.938" v="2161" actId="20577"/>
+        <pc:graphicFrameChg chg="modGraphic">
+          <ac:chgData name="Rich Reba" userId="55db41ab6eb3f845" providerId="LiveId" clId="{0E19DA16-244C-5B50-BE0F-52911DD4CA7E}" dt="2026-08-09T19:33:21.908" v="435" actId="20577"/>
           <ac:graphicFrameMkLst>
             <pc:docMk/>
             <pc:sldMk cId="450257364" sldId="269"/>
@@ -392,13 +345,13 @@
         </pc:graphicFrameChg>
       </pc:sldChg>
       <pc:sldChg chg="modSp mod">
-        <pc:chgData name="Rich Reba" userId="8245d172-5b81-40f1-a13b-b71f02cd6700" providerId="ADAL" clId="{56979323-92D1-2645-918B-5AF322CBD296}" dt="2024-11-01T20:25:24.121" v="2301" actId="14734"/>
+        <pc:chgData name="Rich Reba" userId="55db41ab6eb3f845" providerId="LiveId" clId="{0E19DA16-244C-5B50-BE0F-52911DD4CA7E}" dt="2026-08-09T19:34:30.700" v="534" actId="20577"/>
         <pc:sldMkLst>
           <pc:docMk/>
           <pc:sldMk cId="4255637138" sldId="270"/>
         </pc:sldMkLst>
-        <pc:graphicFrameChg chg="mod modGraphic">
-          <ac:chgData name="Rich Reba" userId="8245d172-5b81-40f1-a13b-b71f02cd6700" providerId="ADAL" clId="{56979323-92D1-2645-918B-5AF322CBD296}" dt="2024-11-01T20:25:24.121" v="2301" actId="14734"/>
+        <pc:graphicFrameChg chg="modGraphic">
+          <ac:chgData name="Rich Reba" userId="55db41ab6eb3f845" providerId="LiveId" clId="{0E19DA16-244C-5B50-BE0F-52911DD4CA7E}" dt="2026-08-09T19:34:30.700" v="534" actId="20577"/>
           <ac:graphicFrameMkLst>
             <pc:docMk/>
             <pc:sldMk cId="4255637138" sldId="270"/>
@@ -407,13 +360,13 @@
         </pc:graphicFrameChg>
       </pc:sldChg>
       <pc:sldChg chg="modSp mod">
-        <pc:chgData name="Rich Reba" userId="8245d172-5b81-40f1-a13b-b71f02cd6700" providerId="ADAL" clId="{56979323-92D1-2645-918B-5AF322CBD296}" dt="2024-11-01T20:28:13.827" v="2307" actId="20577"/>
+        <pc:chgData name="Rich Reba" userId="55db41ab6eb3f845" providerId="LiveId" clId="{0E19DA16-244C-5B50-BE0F-52911DD4CA7E}" dt="2026-08-09T19:34:48.738" v="579" actId="20577"/>
         <pc:sldMkLst>
           <pc:docMk/>
           <pc:sldMk cId="67448461" sldId="271"/>
         </pc:sldMkLst>
-        <pc:graphicFrameChg chg="mod modGraphic">
-          <ac:chgData name="Rich Reba" userId="8245d172-5b81-40f1-a13b-b71f02cd6700" providerId="ADAL" clId="{56979323-92D1-2645-918B-5AF322CBD296}" dt="2024-11-01T20:28:13.827" v="2307" actId="20577"/>
+        <pc:graphicFrameChg chg="modGraphic">
+          <ac:chgData name="Rich Reba" userId="55db41ab6eb3f845" providerId="LiveId" clId="{0E19DA16-244C-5B50-BE0F-52911DD4CA7E}" dt="2026-08-09T19:34:48.738" v="579" actId="20577"/>
           <ac:graphicFrameMkLst>
             <pc:docMk/>
             <pc:sldMk cId="67448461" sldId="271"/>
@@ -422,13 +375,13 @@
         </pc:graphicFrameChg>
       </pc:sldChg>
       <pc:sldChg chg="modSp mod">
-        <pc:chgData name="Rich Reba" userId="8245d172-5b81-40f1-a13b-b71f02cd6700" providerId="ADAL" clId="{56979323-92D1-2645-918B-5AF322CBD296}" dt="2024-11-01T18:58:09.669" v="1845" actId="20577"/>
+        <pc:chgData name="Rich Reba" userId="55db41ab6eb3f845" providerId="LiveId" clId="{0E19DA16-244C-5B50-BE0F-52911DD4CA7E}" dt="2026-08-09T19:35:36.095" v="628" actId="20577"/>
         <pc:sldMkLst>
           <pc:docMk/>
           <pc:sldMk cId="3088802820" sldId="272"/>
         </pc:sldMkLst>
-        <pc:graphicFrameChg chg="mod modGraphic">
-          <ac:chgData name="Rich Reba" userId="8245d172-5b81-40f1-a13b-b71f02cd6700" providerId="ADAL" clId="{56979323-92D1-2645-918B-5AF322CBD296}" dt="2024-11-01T18:58:09.669" v="1845" actId="20577"/>
+        <pc:graphicFrameChg chg="modGraphic">
+          <ac:chgData name="Rich Reba" userId="55db41ab6eb3f845" providerId="LiveId" clId="{0E19DA16-244C-5B50-BE0F-52911DD4CA7E}" dt="2026-08-09T19:35:36.095" v="628" actId="20577"/>
           <ac:graphicFrameMkLst>
             <pc:docMk/>
             <pc:sldMk cId="3088802820" sldId="272"/>
@@ -436,29 +389,14 @@
           </ac:graphicFrameMkLst>
         </pc:graphicFrameChg>
       </pc:sldChg>
-      <pc:sldChg chg="del">
-        <pc:chgData name="Rich Reba" userId="8245d172-5b81-40f1-a13b-b71f02cd6700" providerId="ADAL" clId="{56979323-92D1-2645-918B-5AF322CBD296}" dt="2024-10-22T01:09:44.916" v="7" actId="2696"/>
-        <pc:sldMkLst>
-          <pc:docMk/>
-          <pc:sldMk cId="3864669982" sldId="274"/>
-        </pc:sldMkLst>
-      </pc:sldChg>
-      <pc:sldChg chg="addSp delSp modSp mod">
-        <pc:chgData name="Rich Reba" userId="8245d172-5b81-40f1-a13b-b71f02cd6700" providerId="ADAL" clId="{56979323-92D1-2645-918B-5AF322CBD296}" dt="2024-10-22T01:10:45.517" v="53" actId="20577"/>
+      <pc:sldChg chg="modSp">
+        <pc:chgData name="Rich Reba" userId="55db41ab6eb3f845" providerId="LiveId" clId="{0E19DA16-244C-5B50-BE0F-52911DD4CA7E}" dt="2026-08-09T19:40:57.788" v="838"/>
         <pc:sldMkLst>
           <pc:docMk/>
           <pc:sldMk cId="2639682451" sldId="275"/>
         </pc:sldMkLst>
-        <pc:graphicFrameChg chg="del">
-          <ac:chgData name="Rich Reba" userId="8245d172-5b81-40f1-a13b-b71f02cd6700" providerId="ADAL" clId="{56979323-92D1-2645-918B-5AF322CBD296}" dt="2024-10-22T01:09:55.436" v="8" actId="478"/>
-          <ac:graphicFrameMkLst>
-            <pc:docMk/>
-            <pc:sldMk cId="2639682451" sldId="275"/>
-            <ac:graphicFrameMk id="5" creationId="{4B70F3A5-8062-29A2-30D0-2783CB3DFCCA}"/>
-          </ac:graphicFrameMkLst>
-        </pc:graphicFrameChg>
-        <pc:graphicFrameChg chg="add mod modGraphic">
-          <ac:chgData name="Rich Reba" userId="8245d172-5b81-40f1-a13b-b71f02cd6700" providerId="ADAL" clId="{56979323-92D1-2645-918B-5AF322CBD296}" dt="2024-10-22T01:10:45.517" v="53" actId="20577"/>
+        <pc:graphicFrameChg chg="mod">
+          <ac:chgData name="Rich Reba" userId="55db41ab6eb3f845" providerId="LiveId" clId="{0E19DA16-244C-5B50-BE0F-52911DD4CA7E}" dt="2026-08-09T19:40:57.788" v="838"/>
           <ac:graphicFrameMkLst>
             <pc:docMk/>
             <pc:sldMk cId="2639682451" sldId="275"/>
@@ -467,21 +405,13 @@
         </pc:graphicFrameChg>
       </pc:sldChg>
       <pc:sldChg chg="modSp mod">
-        <pc:chgData name="Rich Reba" userId="8245d172-5b81-40f1-a13b-b71f02cd6700" providerId="ADAL" clId="{56979323-92D1-2645-918B-5AF322CBD296}" dt="2024-11-01T19:15:07.544" v="2201" actId="20577"/>
+        <pc:chgData name="Rich Reba" userId="55db41ab6eb3f845" providerId="LiveId" clId="{0E19DA16-244C-5B50-BE0F-52911DD4CA7E}" dt="2026-08-09T19:30:43.734" v="166" actId="20577"/>
         <pc:sldMkLst>
           <pc:docMk/>
           <pc:sldMk cId="3191730488" sldId="276"/>
         </pc:sldMkLst>
-        <pc:spChg chg="mod">
-          <ac:chgData name="Rich Reba" userId="8245d172-5b81-40f1-a13b-b71f02cd6700" providerId="ADAL" clId="{56979323-92D1-2645-918B-5AF322CBD296}" dt="2024-11-01T19:01:50.363" v="1930" actId="20577"/>
-          <ac:spMkLst>
-            <pc:docMk/>
-            <pc:sldMk cId="3191730488" sldId="276"/>
-            <ac:spMk id="96" creationId="{00000000-0000-0000-0000-000000000000}"/>
-          </ac:spMkLst>
-        </pc:spChg>
-        <pc:graphicFrameChg chg="mod modGraphic">
-          <ac:chgData name="Rich Reba" userId="8245d172-5b81-40f1-a13b-b71f02cd6700" providerId="ADAL" clId="{56979323-92D1-2645-918B-5AF322CBD296}" dt="2024-11-01T19:15:07.544" v="2201" actId="20577"/>
+        <pc:graphicFrameChg chg="modGraphic">
+          <ac:chgData name="Rich Reba" userId="55db41ab6eb3f845" providerId="LiveId" clId="{0E19DA16-244C-5B50-BE0F-52911DD4CA7E}" dt="2026-08-09T19:30:43.734" v="166" actId="20577"/>
           <ac:graphicFrameMkLst>
             <pc:docMk/>
             <pc:sldMk cId="3191730488" sldId="276"/>
@@ -489,60 +419,29 @@
           </ac:graphicFrameMkLst>
         </pc:graphicFrameChg>
       </pc:sldChg>
-      <pc:sldChg chg="addSp delSp modSp mod">
-        <pc:chgData name="Rich Reba" userId="8245d172-5b81-40f1-a13b-b71f02cd6700" providerId="ADAL" clId="{56979323-92D1-2645-918B-5AF322CBD296}" dt="2024-10-25T18:00:36.505" v="746"/>
+      <pc:sldChg chg="modSp mod">
+        <pc:chgData name="Rich Reba" userId="55db41ab6eb3f845" providerId="LiveId" clId="{0E19DA16-244C-5B50-BE0F-52911DD4CA7E}" dt="2026-08-09T19:31:23.796" v="231" actId="20577"/>
         <pc:sldMkLst>
           <pc:docMk/>
           <pc:sldMk cId="368434212" sldId="277"/>
         </pc:sldMkLst>
-        <pc:graphicFrameChg chg="del">
-          <ac:chgData name="Rich Reba" userId="8245d172-5b81-40f1-a13b-b71f02cd6700" providerId="ADAL" clId="{56979323-92D1-2645-918B-5AF322CBD296}" dt="2024-10-25T18:00:35.462" v="745" actId="478"/>
-          <ac:graphicFrameMkLst>
-            <pc:docMk/>
-            <pc:sldMk cId="368434212" sldId="277"/>
-            <ac:graphicFrameMk id="2" creationId="{30929ABE-0A38-27D1-4713-A9783350A181}"/>
-          </ac:graphicFrameMkLst>
-        </pc:graphicFrameChg>
-        <pc:graphicFrameChg chg="add mod">
-          <ac:chgData name="Rich Reba" userId="8245d172-5b81-40f1-a13b-b71f02cd6700" providerId="ADAL" clId="{56979323-92D1-2645-918B-5AF322CBD296}" dt="2024-10-25T18:00:36.505" v="746"/>
+        <pc:graphicFrameChg chg="modGraphic">
+          <ac:chgData name="Rich Reba" userId="55db41ab6eb3f845" providerId="LiveId" clId="{0E19DA16-244C-5B50-BE0F-52911DD4CA7E}" dt="2026-08-09T19:31:23.796" v="231" actId="20577"/>
           <ac:graphicFrameMkLst>
             <pc:docMk/>
             <pc:sldMk cId="368434212" sldId="277"/>
             <ac:graphicFrameMk id="4" creationId="{27601DD6-DAE5-888B-0F9A-3C9911942417}"/>
           </ac:graphicFrameMkLst>
         </pc:graphicFrameChg>
-        <pc:graphicFrameChg chg="add mod">
-          <ac:chgData name="Rich Reba" userId="8245d172-5b81-40f1-a13b-b71f02cd6700" providerId="ADAL" clId="{56979323-92D1-2645-918B-5AF322CBD296}" dt="2024-10-22T01:08:57.812" v="0"/>
-          <ac:graphicFrameMkLst>
-            <pc:docMk/>
-            <pc:sldMk cId="368434212" sldId="277"/>
-            <ac:graphicFrameMk id="4" creationId="{F51ACD9E-B801-18ED-CD12-315AD95F4483}"/>
-          </ac:graphicFrameMkLst>
-        </pc:graphicFrameChg>
       </pc:sldChg>
-      <pc:sldChg chg="modSp add del mod">
-        <pc:chgData name="Rich Reba" userId="8245d172-5b81-40f1-a13b-b71f02cd6700" providerId="ADAL" clId="{56979323-92D1-2645-918B-5AF322CBD296}" dt="2024-11-01T17:53:06.387" v="780" actId="2696"/>
-        <pc:sldMkLst>
-          <pc:docMk/>
-          <pc:sldMk cId="4159369405" sldId="281"/>
-        </pc:sldMkLst>
-        <pc:graphicFrameChg chg="mod modGraphic">
-          <ac:chgData name="Rich Reba" userId="8245d172-5b81-40f1-a13b-b71f02cd6700" providerId="ADAL" clId="{56979323-92D1-2645-918B-5AF322CBD296}" dt="2024-10-22T01:10:36.462" v="31" actId="20577"/>
-          <ac:graphicFrameMkLst>
-            <pc:docMk/>
-            <pc:sldMk cId="4159369405" sldId="281"/>
-            <ac:graphicFrameMk id="5" creationId="{4B70F3A5-8062-29A2-30D0-2783CB3DFCCA}"/>
-          </ac:graphicFrameMkLst>
-        </pc:graphicFrameChg>
-      </pc:sldChg>
-      <pc:sldChg chg="modSp add mod">
-        <pc:chgData name="Rich Reba" userId="8245d172-5b81-40f1-a13b-b71f02cd6700" providerId="ADAL" clId="{56979323-92D1-2645-918B-5AF322CBD296}" dt="2024-10-25T17:59:43.221" v="744" actId="20577"/>
+      <pc:sldChg chg="modSp mod">
+        <pc:chgData name="Rich Reba" userId="55db41ab6eb3f845" providerId="LiveId" clId="{0E19DA16-244C-5B50-BE0F-52911DD4CA7E}" dt="2026-08-09T19:30:27" v="133" actId="20577"/>
         <pc:sldMkLst>
           <pc:docMk/>
           <pc:sldMk cId="2988147867" sldId="282"/>
         </pc:sldMkLst>
         <pc:graphicFrameChg chg="modGraphic">
-          <ac:chgData name="Rich Reba" userId="8245d172-5b81-40f1-a13b-b71f02cd6700" providerId="ADAL" clId="{56979323-92D1-2645-918B-5AF322CBD296}" dt="2024-10-25T17:59:43.221" v="744" actId="20577"/>
+          <ac:chgData name="Rich Reba" userId="55db41ab6eb3f845" providerId="LiveId" clId="{0E19DA16-244C-5B50-BE0F-52911DD4CA7E}" dt="2026-08-09T19:30:27" v="133" actId="20577"/>
           <ac:graphicFrameMkLst>
             <pc:docMk/>
             <pc:sldMk cId="2988147867" sldId="282"/>
@@ -550,14 +449,14 @@
           </ac:graphicFrameMkLst>
         </pc:graphicFrameChg>
       </pc:sldChg>
-      <pc:sldChg chg="modSp add mod">
-        <pc:chgData name="Rich Reba" userId="8245d172-5b81-40f1-a13b-b71f02cd6700" providerId="ADAL" clId="{56979323-92D1-2645-918B-5AF322CBD296}" dt="2024-11-01T17:52:57.480" v="779" actId="20577"/>
+      <pc:sldChg chg="modSp mod">
+        <pc:chgData name="Rich Reba" userId="55db41ab6eb3f845" providerId="LiveId" clId="{0E19DA16-244C-5B50-BE0F-52911DD4CA7E}" dt="2026-08-09T19:36:40.304" v="799" actId="20577"/>
         <pc:sldMkLst>
           <pc:docMk/>
           <pc:sldMk cId="3960435043" sldId="283"/>
         </pc:sldMkLst>
         <pc:graphicFrameChg chg="modGraphic">
-          <ac:chgData name="Rich Reba" userId="8245d172-5b81-40f1-a13b-b71f02cd6700" providerId="ADAL" clId="{56979323-92D1-2645-918B-5AF322CBD296}" dt="2024-11-01T17:52:57.480" v="779" actId="20577"/>
+          <ac:chgData name="Rich Reba" userId="55db41ab6eb3f845" providerId="LiveId" clId="{0E19DA16-244C-5B50-BE0F-52911DD4CA7E}" dt="2026-08-09T19:36:40.304" v="799" actId="20577"/>
           <ac:graphicFrameMkLst>
             <pc:docMk/>
             <pc:sldMk cId="3960435043" sldId="283"/>
@@ -16122,7 +16021,7 @@
             </a:pPr>
             <a:r>
               <a:rPr lang="en-US" dirty="0"/>
-              <a:t>Rich Reba, President</a:t>
+              <a:t>Open Knowledge Sharing Service Leader</a:t>
             </a:r>
           </a:p>
           <a:p>
@@ -16144,7 +16043,7 @@
             </a:pPr>
             <a:r>
               <a:rPr lang="en-US" dirty="0"/>
-              <a:t>November 1, 2024</a:t>
+              <a:t>August 9, 2026</a:t>
             </a:r>
           </a:p>
         </p:txBody>
@@ -16382,7 +16281,7 @@
           <p:nvPr>
             <p:extLst>
               <p:ext uri="{D42A27DB-BD31-4B8C-83A1-F6EECF244321}">
-                <p14:modId xmlns:p14="http://schemas.microsoft.com/office/powerpoint/2010/main" val="2649788065"/>
+                <p14:modId xmlns:p14="http://schemas.microsoft.com/office/powerpoint/2010/main" val="593699632"/>
               </p:ext>
             </p:extLst>
           </p:nvPr>
@@ -16532,7 +16431,7 @@
                           </a:solidFill>
                           <a:effectLst/>
                         </a:rPr>
-                        <a:t> among a Professional Network of 1,000+ initial collaborators while harnessing </a:t>
+                        <a:t> among a Professional Network of 1,000+ initial subscribers while harnessing </a:t>
                       </a:r>
                       <a:r>
                         <a:rPr lang="en-US" sz="1100" b="1" dirty="0">
@@ -16704,7 +16603,7 @@
                           </a:solidFill>
                           <a:effectLst/>
                         </a:rPr>
-                        <a:t>Demand Generation, Customer Acquisition, and Service Fulfillment for our MVP should be focused on ideation among 1,000+ initial collaborators to ensure they are Net Promoters of the Consortium’s services and its core premise.  As our Service mature beyond MVP, and we find new revenue sources, we will be able to invest in more sophisticated Demand Generation, Customer Acquisition, and Service Fulfillment activities to further accelerate growth and impact.</a:t>
+                        <a:t>Demand Generation, Beneficiary Engagement, and Delivery of Service for our MVP should be focused on ideation among 1,000+ initial subscribers to ensure they are Net Promoters of the Consortium’s services and its core premise.  As our Service mature beyond MVP, and we find new revenue sources, we will be able to invest in more sophisticated Demand Generation, Customer Acquisition, and Service Fulfillment activities to further accelerate growth and impact.</a:t>
                       </a:r>
                     </a:p>
                   </a:txBody>
@@ -16827,7 +16726,7 @@
                           </a:solidFill>
                           <a:effectLst/>
                         </a:rPr>
-                        <a:t>An opportunity cost of one 10% fraction of Rich Reba’s time for 2 months, which is equivalent to $10K.</a:t>
+                        <a:t>Estimate:  $10K.</a:t>
                       </a:r>
                       <a:endParaRPr lang="en-US" sz="1100" dirty="0">
                         <a:solidFill>
@@ -17023,7 +16922,7 @@
                           <a:ea typeface="MS Mincho" panose="02020609040205080304" pitchFamily="49" charset="-128"/>
                           <a:cs typeface="Arial" panose="020B0604020202020204" pitchFamily="34" charset="0"/>
                         </a:rPr>
-                        <a:t>Lagging indicators:  Increasing benefit to collaborators, the Tech Services industry, and humanity, as measured by collaborator and patron surveys</a:t>
+                        <a:t>Lagging indicators:  Increasing benefit to subscribers, the Tech Services industry, and humanity, as measured by subscriber and patron surveys</a:t>
                       </a:r>
                       <a:endParaRPr lang="en-US" sz="1100" dirty="0">
                         <a:solidFill>
@@ -17649,7 +17548,7 @@
           <p:nvPr>
             <p:extLst>
               <p:ext uri="{D42A27DB-BD31-4B8C-83A1-F6EECF244321}">
-                <p14:modId xmlns:p14="http://schemas.microsoft.com/office/powerpoint/2010/main" val="2734481687"/>
+                <p14:modId xmlns:p14="http://schemas.microsoft.com/office/powerpoint/2010/main" val="2003878001"/>
               </p:ext>
             </p:extLst>
           </p:nvPr>
@@ -17789,7 +17688,7 @@
                           </a:solidFill>
                           <a:effectLst/>
                         </a:rPr>
-                        <a:t> Service Strategy, Context, Intent, Development Kit, Demand Generation Kit, Customer Acquisition Kit, and Service Fulfillment Kit</a:t>
+                        <a:t> Service Strategy, Context, Intent, Development Kit, Demand Generation Kit, Beneficiaries Engagement Kit, and Delivery of Service Kit</a:t>
                       </a:r>
                       <a:br>
                         <a:rPr lang="en-US" sz="1100" dirty="0">
@@ -18694,7 +18593,7 @@
           <p:nvPr>
             <p:extLst>
               <p:ext uri="{D42A27DB-BD31-4B8C-83A1-F6EECF244321}">
-                <p14:modId xmlns:p14="http://schemas.microsoft.com/office/powerpoint/2010/main" val="2527836621"/>
+                <p14:modId xmlns:p14="http://schemas.microsoft.com/office/powerpoint/2010/main" val="237346242"/>
               </p:ext>
             </p:extLst>
           </p:nvPr>
@@ -18831,7 +18730,7 @@
                           </a:solidFill>
                           <a:effectLst/>
                         </a:rPr>
-                        <a:t>These include Service Strategy, Context, Intent, Development Kit, Demand Generation Kit, Customer Acquisition Kit, and Service Fulfillment Kit components.</a:t>
+                        <a:t>These include Service Strategy, Context, Intent, Development Kit, Demand Generation Kit, Beneficiaries Engagement Kit, and Delivery of Service Kit components.</a:t>
                       </a:r>
                     </a:p>
                   </a:txBody>
@@ -18930,7 +18829,7 @@
                           </a:solidFill>
                           <a:effectLst/>
                         </a:rPr>
-                        <a:t> produced by the AccelRR8 Consortium Non-Profit</a:t>
+                        <a:t> produced by AccelRR8 LLC</a:t>
                       </a:r>
                     </a:p>
                     <a:p>
@@ -19595,7 +19494,7 @@
           <p:nvPr>
             <p:extLst>
               <p:ext uri="{D42A27DB-BD31-4B8C-83A1-F6EECF244321}">
-                <p14:modId xmlns:p14="http://schemas.microsoft.com/office/powerpoint/2010/main" val="2159440746"/>
+                <p14:modId xmlns:p14="http://schemas.microsoft.com/office/powerpoint/2010/main" val="3776199952"/>
               </p:ext>
             </p:extLst>
           </p:nvPr>
@@ -19859,14 +19758,7 @@
                     <a:p>
                       <a:r>
                         <a:rPr lang="en-US" sz="1600" b="0" dirty="0"/>
-                        <a:t>Customer </a:t>
-                      </a:r>
-                      <a:br>
-                        <a:rPr lang="en-US" sz="1600" b="0" dirty="0"/>
-                      </a:br>
-                      <a:r>
-                        <a:rPr lang="en-US" sz="1600" b="0" dirty="0"/>
-                        <a:t>Acquisition Kit</a:t>
+                        <a:t>Beneficiaries Engagement Kit</a:t>
                       </a:r>
                     </a:p>
                   </a:txBody>
@@ -19880,7 +19772,7 @@
                       <a:pPr lvl="2"/>
                       <a:r>
                         <a:rPr lang="en-US" dirty="0"/>
-                        <a:t>&lt;Descriptions of Collateral and Tools used by Customer Acquisition to engage with specific potential Customers about the service&gt;</a:t>
+                        <a:t>&lt;Descriptions of Collateral and Tools used by Beneficiaries Engagement to engage with specific potential potential beneficiaries about the service&gt;</a:t>
                       </a:r>
                       <a:endParaRPr lang="en-US" sz="1400" b="0" i="0" u="none" strike="noStrike" cap="none" dirty="0">
                         <a:solidFill>
@@ -19910,14 +19802,14 @@
                     <a:p>
                       <a:r>
                         <a:rPr lang="en-US" sz="1600" b="0" dirty="0"/>
-                        <a:t>Service </a:t>
+                        <a:t>Delivery of </a:t>
                       </a:r>
                       <a:br>
                         <a:rPr lang="en-US" sz="1600" b="0" dirty="0"/>
                       </a:br>
                       <a:r>
                         <a:rPr lang="en-US" sz="1600" b="0" dirty="0"/>
-                        <a:t>Fulfillment Kit</a:t>
+                        <a:t>Service Kit</a:t>
                       </a:r>
                     </a:p>
                   </a:txBody>
@@ -19930,7 +19822,7 @@
                     <a:p>
                       <a:r>
                         <a:rPr lang="en-US" dirty="0"/>
-                        <a:t>&lt;Descriptions of Collateral and Tools used by Service Fulfillment to engage with Customers about the service&gt;</a:t>
+                        <a:t>&lt;Descriptions of Collateral and Tools used by Delivery of Services to engage with beneficiaries about the service&gt;</a:t>
                       </a:r>
                     </a:p>
                   </a:txBody>
@@ -21071,7 +20963,7 @@
           <p:nvPr>
             <p:extLst>
               <p:ext uri="{D42A27DB-BD31-4B8C-83A1-F6EECF244321}">
-                <p14:modId xmlns:p14="http://schemas.microsoft.com/office/powerpoint/2010/main" val="3435381267"/>
+                <p14:modId xmlns:p14="http://schemas.microsoft.com/office/powerpoint/2010/main" val="1315964776"/>
               </p:ext>
             </p:extLst>
           </p:nvPr>
@@ -21333,14 +21225,7 @@
                     <a:p>
                       <a:r>
                         <a:rPr lang="en-US" sz="1600" b="0" dirty="0"/>
-                        <a:t>Customer </a:t>
-                      </a:r>
-                      <a:br>
-                        <a:rPr lang="en-US" sz="1600" b="0" dirty="0"/>
-                      </a:br>
-                      <a:r>
-                        <a:rPr lang="en-US" sz="1600" b="0" dirty="0"/>
-                        <a:t>Acquisition Kit</a:t>
+                        <a:t>Beneficiaries Engagement Kit</a:t>
                       </a:r>
                     </a:p>
                   </a:txBody>
@@ -21354,7 +21239,7 @@
                       <a:pPr lvl="2"/>
                       <a:r>
                         <a:rPr lang="en-US" dirty="0"/>
-                        <a:t>&lt;Descriptions of Collateral and Tools used by Customer Acquisition to engage with specific potential Customers about the offering&gt;</a:t>
+                        <a:t>&lt;Descriptions of Collateral and Tools used by Beneficiaries Engagement to engage with specific potential potential beneficiaries about the service&gt;</a:t>
                       </a:r>
                       <a:endParaRPr lang="en-US" sz="1400" b="0" i="0" u="none" strike="noStrike" cap="none" dirty="0">
                         <a:solidFill>
@@ -21384,14 +21269,14 @@
                     <a:p>
                       <a:r>
                         <a:rPr lang="en-US" sz="1600" b="0" dirty="0"/>
-                        <a:t>Service </a:t>
+                        <a:t>Delivery of </a:t>
                       </a:r>
                       <a:br>
                         <a:rPr lang="en-US" sz="1600" b="0" dirty="0"/>
                       </a:br>
                       <a:r>
                         <a:rPr lang="en-US" sz="1600" b="0" dirty="0"/>
-                        <a:t>Fulfillment Kit</a:t>
+                        <a:t>Service Kit</a:t>
                       </a:r>
                     </a:p>
                   </a:txBody>
@@ -21404,7 +21289,7 @@
                     <a:p>
                       <a:r>
                         <a:rPr lang="en-US" dirty="0"/>
-                        <a:t>&lt;Descriptions of Collateral and Tools used by Service Fulfillment to engage with Customers about the offering&gt;</a:t>
+                        <a:t>&lt;Descriptions of Collateral and Tools used by Delivery of Services to engage with beneficiaries about the service&gt;</a:t>
                       </a:r>
                     </a:p>
                   </a:txBody>
@@ -21968,7 +21853,7 @@
           <p:nvPr>
             <p:extLst>
               <p:ext uri="{D42A27DB-BD31-4B8C-83A1-F6EECF244321}">
-                <p14:modId xmlns:p14="http://schemas.microsoft.com/office/powerpoint/2010/main" val="1625000630"/>
+                <p14:modId xmlns:p14="http://schemas.microsoft.com/office/powerpoint/2010/main" val="1394229560"/>
               </p:ext>
             </p:extLst>
           </p:nvPr>
@@ -22105,7 +21990,7 @@
                     <a:p>
                       <a:r>
                         <a:rPr lang="en-US" dirty="0"/>
-                        <a:t>Rich Reba</a:t>
+                        <a:t>Open Knowledge Sharing Service Leader</a:t>
                       </a:r>
                     </a:p>
                   </a:txBody>
@@ -22464,7 +22349,7 @@
                       </a:pPr>
                       <a:r>
                         <a:rPr lang="en-US" b="1" dirty="0"/>
-                        <a:t>Collaborators</a:t>
+                        <a:t>Subscribers</a:t>
                       </a:r>
                       <a:r>
                         <a:rPr lang="en-US" dirty="0"/>
@@ -22539,7 +22424,7 @@
                     <a:p>
                       <a:r>
                         <a:rPr lang="en-US" dirty="0"/>
-                        <a:t>1000 collaborators in the AccelRR8 professional network who are net promoters of this service</a:t>
+                        <a:t>1000 subscribers in the AccelRR8 professional network who are net promoters of this service</a:t>
                       </a:r>
                     </a:p>
                   </a:txBody>
@@ -23399,7 +23284,7 @@
           <p:nvPr>
             <p:extLst>
               <p:ext uri="{D42A27DB-BD31-4B8C-83A1-F6EECF244321}">
-                <p14:modId xmlns:p14="http://schemas.microsoft.com/office/powerpoint/2010/main" val="3593385893"/>
+                <p14:modId xmlns:p14="http://schemas.microsoft.com/office/powerpoint/2010/main" val="581843773"/>
               </p:ext>
             </p:extLst>
           </p:nvPr>
@@ -23633,7 +23518,7 @@
                       </a:pPr>
                       <a:r>
                         <a:rPr lang="en-US" dirty="0"/>
-                        <a:t>       Do collaborators prefer this over other services?   13:  the “grow value exponentially at scale” skill is valued</a:t>
+                        <a:t>       Do subscribers prefer this over other services?   13:  the “grow value exponentially at scale” skill is valued</a:t>
                       </a:r>
                     </a:p>
                     <a:p>
@@ -23783,7 +23668,7 @@
                       </a:pPr>
                       <a:r>
                         <a:rPr lang="en-US" dirty="0"/>
-                        <a:t>       What is the current effect on collaborator satisfaction?   13:  collaborators want knowledge they can use</a:t>
+                        <a:t>       What is the current effect on subscriber satisfaction?   13:  subscribers want knowledge they can use</a:t>
                       </a:r>
                     </a:p>
                     <a:p>
@@ -23833,7 +23718,7 @@
                       </a:pPr>
                       <a:r>
                         <a:rPr lang="en-US" dirty="0"/>
-                        <a:t>       Reduces the risk of this or future delivery?   13:  viral ideation is needed to attract and retain collaborators</a:t>
+                        <a:t>       Reduces the risk of this or future delivery?   13:  viral ideation is needed to attract and retain subscribers</a:t>
                       </a:r>
                     </a:p>
                     <a:p>
@@ -23858,7 +23743,7 @@
                       </a:pPr>
                       <a:r>
                         <a:rPr lang="en-US" dirty="0"/>
-                        <a:t>       Is there value in the information we receive?  13:  willingness of collaborators to ideate and use the BOK</a:t>
+                        <a:t>       Is there value in the information we receive?  13:  willingness of subscribers to ideate and use the BOK</a:t>
                       </a:r>
                     </a:p>
                     <a:p>
@@ -23883,7 +23768,7 @@
                       </a:pPr>
                       <a:r>
                         <a:rPr lang="en-US" dirty="0"/>
-                        <a:t>       Enable new business opportunities?  13:  collaborators may be interested in certifications, etc.</a:t>
+                        <a:t>       Enable new business opportunities?  13:  subscribers may be interested in certifications, etc.</a:t>
                       </a:r>
                     </a:p>
                     <a:p>
@@ -24739,7 +24624,7 @@
           <p:nvPr>
             <p:extLst>
               <p:ext uri="{D42A27DB-BD31-4B8C-83A1-F6EECF244321}">
-                <p14:modId xmlns:p14="http://schemas.microsoft.com/office/powerpoint/2010/main" val="4229000918"/>
+                <p14:modId xmlns:p14="http://schemas.microsoft.com/office/powerpoint/2010/main" val="280311085"/>
               </p:ext>
             </p:extLst>
           </p:nvPr>
@@ -24826,7 +24711,7 @@
                           </a:solidFill>
                           <a:effectLst/>
                         </a:rPr>
-                        <a:t>Collaborators can share ideas with one another via an online platform</a:t>
+                        <a:t>Subscribers can share ideas with one another via an online platform</a:t>
                       </a:r>
                     </a:p>
                     <a:p>
@@ -24873,7 +24758,7 @@
                           </a:solidFill>
                           <a:effectLst/>
                         </a:rPr>
-                        <a:t>Collaborators can access the AccelRR8 Body of Knowledge, including the AccelRR8 Framework</a:t>
+                        <a:t>Subscribers can access the AccelRR8 Body of Knowledge, including the AccelRR8 Framework</a:t>
                       </a:r>
                     </a:p>
                     <a:p>
@@ -24920,7 +24805,7 @@
                           </a:solidFill>
                           <a:effectLst/>
                         </a:rPr>
-                        <a:t>Collaborators can participate in Consortium webinars</a:t>
+                        <a:t>Subscribers can participate in Consortium webinars</a:t>
                       </a:r>
                     </a:p>
                     <a:p>
@@ -26049,7 +25934,7 @@
           <p:nvPr>
             <p:extLst>
               <p:ext uri="{D42A27DB-BD31-4B8C-83A1-F6EECF244321}">
-                <p14:modId xmlns:p14="http://schemas.microsoft.com/office/powerpoint/2010/main" val="4194610857"/>
+                <p14:modId xmlns:p14="http://schemas.microsoft.com/office/powerpoint/2010/main" val="4257362467"/>
               </p:ext>
             </p:extLst>
           </p:nvPr>
@@ -26283,7 +26168,7 @@
                       </a:pPr>
                       <a:r>
                         <a:rPr lang="en-US" dirty="0"/>
-                        <a:t>       Do collaborators prefer this over other services?   13:  the “grow value exponentially at scale” skill is valued</a:t>
+                        <a:t>       Do subscribers prefer this over other services?   13:  the “grow value exponentially at scale” skill is valued</a:t>
                       </a:r>
                     </a:p>
                     <a:p>
@@ -26433,7 +26318,7 @@
                       </a:pPr>
                       <a:r>
                         <a:rPr lang="en-US" dirty="0"/>
-                        <a:t>       What is the current effect on collaborator satisfaction?   13:  collaborators want knowledge they can use</a:t>
+                        <a:t>       What is the current effect on subscriber satisfaction?   13:  subscribers want knowledge they can use</a:t>
                       </a:r>
                     </a:p>
                     <a:p>
@@ -26483,7 +26368,7 @@
                       </a:pPr>
                       <a:r>
                         <a:rPr lang="en-US" dirty="0"/>
-                        <a:t>       Reduces the risk of this or future delivery?   13:  viral ideation is needed to attract and retain collaborators</a:t>
+                        <a:t>       Reduces the risk of this or future delivery?   13:  viral ideation is needed to attract and retain subscribers</a:t>
                       </a:r>
                     </a:p>
                     <a:p>
@@ -26508,7 +26393,7 @@
                       </a:pPr>
                       <a:r>
                         <a:rPr lang="en-US" dirty="0"/>
-                        <a:t>       Is there value in the information we receive?  13:  willingness of collaborators to ideate and use the BOK</a:t>
+                        <a:t>       Is there value in the information we receive?  13:  willingness of subscribers to ideate and use the BOK</a:t>
                       </a:r>
                     </a:p>
                     <a:p>
@@ -26533,7 +26418,7 @@
                       </a:pPr>
                       <a:r>
                         <a:rPr lang="en-US" dirty="0"/>
-                        <a:t>       Enable new business opportunities?  13:  collaborators may be interested in certifications, etc.</a:t>
+                        <a:t>       Enable new business opportunities?  13:  subscribers may be interested in certifications, etc.</a:t>
                       </a:r>
                     </a:p>
                     <a:p>
@@ -26741,7 +26626,7 @@
           <p:nvPr>
             <p:extLst>
               <p:ext uri="{D42A27DB-BD31-4B8C-83A1-F6EECF244321}">
-                <p14:modId xmlns:p14="http://schemas.microsoft.com/office/powerpoint/2010/main" val="433248742"/>
+                <p14:modId xmlns:p14="http://schemas.microsoft.com/office/powerpoint/2010/main" val="394072148"/>
               </p:ext>
             </p:extLst>
           </p:nvPr>
@@ -26883,7 +26768,7 @@
                           </a:solidFill>
                           <a:effectLst/>
                         </a:rPr>
-                        <a:t>Rich Reba</a:t>
+                        <a:t>Open Knowledge Sharing Service Leader</a:t>
                       </a:r>
                     </a:p>
                   </a:txBody>
@@ -26944,34 +26829,7 @@
                           </a:solidFill>
                           <a:effectLst/>
                         </a:rPr>
-                        <a:t>Core Boosters:  Board Members, Sumo </a:t>
-                      </a:r>
-                      <a:r>
-                        <a:rPr lang="en-US" sz="1100" dirty="0" err="1">
-                          <a:solidFill>
-                            <a:schemeClr val="tx1"/>
-                          </a:solidFill>
-                          <a:effectLst/>
-                        </a:rPr>
-                        <a:t>Mitro</a:t>
-                      </a:r>
-                      <a:r>
-                        <a:rPr lang="en-US" sz="1100" dirty="0">
-                          <a:solidFill>
-                            <a:schemeClr val="tx1"/>
-                          </a:solidFill>
-                          <a:effectLst/>
-                        </a:rPr>
-                        <a:t>, Pete </a:t>
-                      </a:r>
-                      <a:r>
-                        <a:rPr lang="en-US" sz="1100" dirty="0" err="1">
-                          <a:solidFill>
-                            <a:schemeClr val="tx1"/>
-                          </a:solidFill>
-                          <a:effectLst/>
-                        </a:rPr>
-                        <a:t>Tseronis</a:t>
+                        <a:t>Core Boosters:  Board Members, Board Advisors</a:t>
                       </a:r>
                       <a:endParaRPr lang="en-US" sz="1100" dirty="0">
                         <a:solidFill>
@@ -27443,7 +27301,7 @@
                           </a:solidFill>
                           <a:effectLst/>
                         </a:rPr>
-                        <a:t>Collaborators: </a:t>
+                        <a:t>Subscribers: </a:t>
                       </a:r>
                       <a:r>
                         <a:rPr lang="en-US" sz="1100" dirty="0">
@@ -27452,7 +27310,7 @@
                           </a:solidFill>
                           <a:effectLst/>
                         </a:rPr>
-                        <a:t>improve their professional network, skills, brand, and career opportunities as measured via survey of collaborators</a:t>
+                        <a:t>improve their professional network, skills, brand, and career opportunities as measured via survey of subscribers</a:t>
                       </a:r>
                       <a:br>
                         <a:rPr lang="en-US" sz="1100" dirty="0">
@@ -27478,7 +27336,7 @@
                           </a:solidFill>
                           <a:effectLst/>
                         </a:rPr>
-                        <a:t>cross-company learning among leaders with scarce talents as measured via survey of collaborators</a:t>
+                        <a:t>cross-company learning among leaders with scarce talents as measured via survey of subscribers</a:t>
                       </a:r>
                       <a:br>
                         <a:rPr lang="en-US" sz="1100" dirty="0">
@@ -27522,7 +27380,7 @@
                           </a:solidFill>
                           <a:effectLst/>
                         </a:rPr>
-                        <a:t>) as measured via survey of collaborators</a:t>
+                        <a:t>) as measured via survey of subscribers</a:t>
                       </a:r>
                     </a:p>
                   </a:txBody>
@@ -27583,7 +27441,7 @@
                           </a:solidFill>
                           <a:effectLst/>
                         </a:rPr>
-                        <a:t>1000 collaborators participating in the AccelRR8 Consortium professional network</a:t>
+                        <a:t>1000 subscribers participating in the AccelRR8 Consortium professional network</a:t>
                       </a:r>
                       <a:br>
                         <a:rPr lang="en-US" sz="1100" dirty="0">
@@ -27600,7 +27458,7 @@
                           </a:solidFill>
                           <a:effectLst/>
                         </a:rPr>
-                        <a:t>are Net Promoters of this service as measured via survey of collaborators.</a:t>
+                        <a:t>are Net Promoters of this service as measured via survey of subscribers.</a:t>
                       </a:r>
                       <a:endParaRPr lang="en-US" sz="1100" dirty="0">
                         <a:solidFill>
@@ -28125,7 +27983,7 @@
           <p:nvPr>
             <p:extLst>
               <p:ext uri="{D42A27DB-BD31-4B8C-83A1-F6EECF244321}">
-                <p14:modId xmlns:p14="http://schemas.microsoft.com/office/powerpoint/2010/main" val="3857767168"/>
+                <p14:modId xmlns:p14="http://schemas.microsoft.com/office/powerpoint/2010/main" val="3754713915"/>
               </p:ext>
             </p:extLst>
           </p:nvPr>
@@ -28212,7 +28070,7 @@
                           </a:solidFill>
                           <a:effectLst/>
                         </a:rPr>
-                        <a:t>Collaborators can share ideas with one another via an online platform</a:t>
+                        <a:t>Subscribers can share ideas with one another via an online platform</a:t>
                       </a:r>
                     </a:p>
                     <a:p>
@@ -28237,7 +28095,7 @@
                           </a:solidFill>
                           <a:effectLst/>
                         </a:rPr>
-                        <a:t>Collaborators can access the AccelRR8 Body of Knowledge, including the AccelRR8 Framework</a:t>
+                        <a:t>Subscribers can access the AccelRR8 Body of Knowledge, including the AccelRR8 Framework</a:t>
                       </a:r>
                     </a:p>
                     <a:p>
@@ -28262,7 +28120,7 @@
                           </a:solidFill>
                           <a:effectLst/>
                         </a:rPr>
-                        <a:t>Collaborators can participate in Consortium webinars</a:t>
+                        <a:t>Subscribers can participate in Consortium webinars</a:t>
                       </a:r>
                     </a:p>
                   </a:txBody>
@@ -28703,7 +28561,7 @@
                           </a:solidFill>
                           <a:effectLst/>
                         </a:rPr>
-                        <a:t>Collaborators join and use a free online platform to share ideas with one another</a:t>
+                        <a:t>Subscribers join and use a free online platform to share ideas with one another</a:t>
                       </a:r>
                     </a:p>
                     <a:p>
@@ -28728,7 +28586,7 @@
                           </a:solidFill>
                           <a:effectLst/>
                         </a:rPr>
-                        <a:t>Collaborators visit the AccelRR8 Body of Knowledge published on a free blog site</a:t>
+                        <a:t>Subscribers visit the AccelRR8 Body of Knowledge published on a free blog site</a:t>
                       </a:r>
                     </a:p>
                     <a:p>
@@ -28753,7 +28611,7 @@
                           </a:solidFill>
                           <a:effectLst/>
                         </a:rPr>
-                        <a:t>Collaborators sign up for and view free AccelRR8 Consortium Webinars</a:t>
+                        <a:t>Subscribers sign up for and view free AccelRR8 Consortium Webinars</a:t>
                       </a:r>
                     </a:p>
                   </a:txBody>
@@ -28909,7 +28767,7 @@
                           </a:solidFill>
                           <a:effectLst/>
                         </a:rPr>
-                        <a:t>MVP desirability, viability, feasibility, and sustainability were verified by the Board of Directors as well as a subset of Advisors and Initial Collaborators.</a:t>
+                        <a:t>MVP desirability, viability, feasibility, and sustainability were verified by the Board of Directors as well as a subset of Advisors and Initial Subscribers.</a:t>
                       </a:r>
                       <a:endParaRPr lang="en-US" sz="1100" b="0" i="0" u="none" strike="noStrike" cap="none" dirty="0">
                         <a:solidFill>

</xml_diff>